<commit_message>
fix: a dead RPC is a refusal, not a zero; fallback RPCs; media rebuilt from the new receipt
</commit_message>
<xml_diff>
--- a/MUSD-Proof-deck.pptx
+++ b/MUSD-Proof-deck.pptx
@@ -3689,7 +3689,7 @@
                             <a:srgbClr val="111418"/>
                           </a:solidFill>
                         </a:rPr>
-                        <a:t>$80,580</a:t>
+                        <a:t>$80,769</a:t>
                       </a:r>
                     </a:p>
                   </a:txBody>
@@ -3976,7 +3976,7 @@
                             <a:srgbClr val="111418"/>
                           </a:solidFill>
                         </a:rPr>
-                        <a:t>101.25x</a:t>
+                        <a:t>101.48x</a:t>
                       </a:r>
                     </a:p>
                   </a:txBody>
@@ -4012,7 +4012,7 @@
                             <a:srgbClr val="111418"/>
                           </a:solidFill>
                         </a:rPr>
-                        <a:t>4.54%</a:t>
+                        <a:t>4.55%</a:t>
                       </a:r>
                     </a:p>
                   </a:txBody>
@@ -4277,7 +4277,7 @@
                   <a:srgbClr val="111418"/>
                 </a:solidFill>
               </a:rPr>
-              <a:t>statement_sha256 = 01d32404e733b3fc7d61f2dfffb39fd4…</a:t>
+              <a:t>statement_sha256 = 54c8c141bbce34b3ea05611b7934f9e5…</a:t>
             </a:r>
           </a:p>
           <a:p>

</xml_diff>